<commit_message>
Fix slides 2-3 for treatment-response framing
</commit_message>
<xml_diff>
--- a/healthier_checkin_v2.pptx
+++ b/healthier_checkin_v2.pptx
@@ -711,7 +711,7 @@
           <a:lstStyle/>
           <a:p>
             <a:r>
-              <a:t>Plain story: we found the cancer patients, and we noticed WHEN they show up - usually already diagnosed. That single fact drives the next slide.</a:t>
+              <a:t>We found the cancer patients, and the key point is that most come to Mayo FOR TREATMENT. So we have the before-and-after treatment data - which is what the next slide builds on.</a:t>
             </a:r>
           </a:p>
         </p:txBody>
@@ -781,7 +781,7 @@
           <a:lstStyle/>
           <a:p>
             <a:r>
-              <a:t>This is the key decision. We're NOT chasing early detection because the pre-diagnosis data isn't here. Treatment response is the honest fit. Say we're still finalizing with mentors.</a:t>
+              <a:t>The key decision. NOT early detection (pre-diagnosis data isn't here). Treatment response is the honest fit, with ~20,000 patients who have a clear did-it-come-back outcome. Still finalizing exact question with mentors.</a:t>
             </a:r>
           </a:p>
         </p:txBody>
@@ -16869,17 +16869,12 @@
           </a:p>
           <a:p>
             <a:r>
-              <a:t>We narrowed to about 60,000 patients who have enough history for us to study.</a:t>
-            </a:r>
-          </a:p>
-          <a:p>
-            <a:r>
-              <a:t>Most were diagnosed somewhere else first and came to Mayo for treatment - only a small share were first diagnosed at Mayo.</a:t>
-            </a:r>
-          </a:p>
-          <a:p>
-            <a:r>
-              <a:t>The good news: most still have years of earlier Mayo lab results, which is what our model would use.</a:t>
+              <a:t>Even when first diagnosed elsewhere, tens of thousands came to Mayo for their treatment - about 76,000 with treatment we can track.</a:t>
+            </a:r>
+          </a:p>
+          <a:p>
+            <a:r>
+              <a:t>That gives us what a treatment study needs: what the patient looked like before treatment, and what happened after.</a:t>
             </a:r>
           </a:p>
         </p:txBody>
@@ -16939,22 +16934,22 @@
           <a:lstStyle/>
           <a:p>
             <a:r>
-              <a:t>Predicting cancer BEFORE diagnosis needs a patient's history from before they arrived - and for most Mayo patients that lives at the outside hospital that diagnosed them.</a:t>
-            </a:r>
-          </a:p>
-          <a:p>
-            <a:r>
-              <a:t>So early detection doesn't fit Mayo well.</a:t>
-            </a:r>
-          </a:p>
-          <a:p>
-            <a:r>
-              <a:t>What DOES fit: what happens after treatment starts - whether the cancer responds, or comes back - because that all happens here.</a:t>
-            </a:r>
-          </a:p>
-          <a:p>
-            <a:r>
-              <a:t>We're leaning toward a treatment-response study, and finalizing the exact question with our mentors.</a:t>
+              <a:t>Predicting cancer BEFORE diagnosis needs the run-up data - and for most Mayo patients that lives at the outside hospital that diagnosed them. So early detection doesn't fit here.</a:t>
+            </a:r>
+          </a:p>
+          <a:p>
+            <a:r>
+              <a:t>Treatment response DOES fit - treatment and follow-up both happen at Mayo.</a:t>
+            </a:r>
+          </a:p>
+          <a:p>
+            <a:r>
+              <a:t>About 20,000 patients already have a clear outcome we can measure: whether the cancer came back within two years.</a:t>
+            </a:r>
+          </a:p>
+          <a:p>
+            <a:r>
+              <a:t>We're leaning this way, and finalizing the exact question with our mentors.</a:t>
             </a:r>
           </a:p>
         </p:txBody>

</xml_diff>

<commit_message>
Fix slide 5: use bulleted layout (large-headline layout overflowed)
</commit_message>
<xml_diff>
--- a/healthier_checkin_v2.pptx
+++ b/healthier_checkin_v2.pptx
@@ -921,7 +921,7 @@
           <a:lstStyle/>
           <a:p>
             <a:r>
-              <a:t>IMPORTANT bridge: Oncoformer is technically an early-detection model, but we said no to early detection. So be explicit: it inspires our METHOD, not our TASK. We adapt the approach to treatment response. That keeps this slide consistent with slide 2.</a:t>
+              <a:t>IMPORTANT bridge: Oncoformer is technically an early-detection model, but we said no to early detection. So be explicit: it inspires our METHOD, not our TASK. We adapt the approach to treatment response. That keeps this slide consistent with slide 3.</a:t>
             </a:r>
           </a:p>
         </p:txBody>
@@ -17236,72 +17236,31 @@
             <a:spLocks noGrp="1"/>
           </p:cNvSpPr>
           <p:nvPr>
-            <p:ph idx="11"/>
+            <p:ph idx="1"/>
           </p:nvPr>
         </p:nvSpPr>
         <p:spPr/>
         <p:txBody>
-          <a:bodyPr/>
+          <a:bodyPr wrap="square"/>
           <a:lstStyle/>
           <a:p>
             <a:r>
-              <a:rPr b="1"/>
-              <a:t>What excites us</a:t>
-            </a:r>
-          </a:p>
-          <a:p>
-            <a:r>
-              <a:rPr sz="1200"/>
-              <a:t>The approach - one model learning from ordinary labs and history - not the specific task.</a:t>
-            </a:r>
-          </a:p>
-        </p:txBody>
-      </p:sp>
-      <p:sp>
-        <p:nvSpPr>
-          <p:cNvPr id="4" name="Content Placeholder 3"/>
-          <p:cNvSpPr>
-            <a:spLocks noGrp="1"/>
-          </p:cNvSpPr>
-          <p:nvPr>
-            <p:ph idx="12"/>
-          </p:nvPr>
-        </p:nvSpPr>
-        <p:spPr/>
-        <p:txBody>
-          <a:bodyPr/>
-          <a:lstStyle/>
-          <a:p>
-            <a:r>
-              <a:rPr b="1"/>
-              <a:t>How we'd use it</a:t>
-            </a:r>
-          </a:p>
-          <a:p>
-            <a:r>
-              <a:rPr sz="1200"/>
-              <a:t>Adapt that same approach to a question that fits Mayo: treatment response. Kicks off our literature dive.</a:t>
-            </a:r>
-          </a:p>
-        </p:txBody>
-      </p:sp>
-      <p:sp>
-        <p:nvSpPr>
-          <p:cNvPr id="5" name="Text Placeholder 4"/>
-          <p:cNvSpPr>
-            <a:spLocks noGrp="1"/>
-          </p:cNvSpPr>
-          <p:nvPr>
-            <p:ph type="body" idx="13" sz="quarter"/>
-          </p:nvPr>
-        </p:nvSpPr>
-        <p:spPr/>
-        <p:txBody>
-          <a:bodyPr/>
-          <a:lstStyle/>
-          <a:p>
-            <a:r>
-              <a:t>A 2026 paper (in the journal Cell) that used one AI model to read routine clinical data over time and predict cancer outcomes.</a:t>
+              <a:t>A 2026 paper (in the journal Cell) used one AI model to read routine clinical data over time and predict cancer outcomes.</a:t>
+            </a:r>
+          </a:p>
+          <a:p>
+            <a:r>
+              <a:t>What excites us is the approach - one model learning from ordinary labs and history - not the specific task.</a:t>
+            </a:r>
+          </a:p>
+          <a:p>
+            <a:r>
+              <a:t>We'd adapt that same approach to a question that fits Mayo: treatment response.</a:t>
+            </a:r>
+          </a:p>
+          <a:p>
+            <a:r>
+              <a:t>It's kicking off our dive into the related research.</a:t>
             </a:r>
           </a:p>
         </p:txBody>

</xml_diff>

<commit_message>
Add Oncoformer figure to slide 5 with attribution
</commit_message>
<xml_diff>
--- a/healthier_checkin_v2.pptx
+++ b/healthier_checkin_v2.pptx
@@ -921,7 +921,7 @@
           <a:lstStyle/>
           <a:p>
             <a:r>
-              <a:t>IMPORTANT bridge: Oncoformer is technically an early-detection model, but we said no to early detection. So be explicit: it inspires our METHOD, not our TASK. We adapt the approach to treatment response. That keeps this slide consistent with slide 3.</a:t>
+              <a:t>IMPORTANT bridge: Oncoformer is technically an early-detection model, but we said no to early detection. So be explicit: it inspires our METHOD, not our TASK. We adapt the approach to treatment response. The figure is the authors' own - cite it.</a:t>
             </a:r>
           </a:p>
         </p:txBody>
@@ -17239,28 +17239,90 @@
             <p:ph idx="1"/>
           </p:nvPr>
         </p:nvSpPr>
-        <p:spPr/>
+        <p:spPr>
+          <a:xfrm>
+            <a:off x="822960" y="2103120"/>
+            <a:ext cx="5577840" cy="3931920"/>
+          </a:xfrm>
+        </p:spPr>
         <p:txBody>
           <a:bodyPr wrap="square"/>
           <a:lstStyle/>
           <a:p>
             <a:r>
-              <a:t>A 2026 paper (in the journal Cell) used one AI model to read routine clinical data over time and predict cancer outcomes.</a:t>
-            </a:r>
-          </a:p>
-          <a:p>
-            <a:r>
-              <a:t>What excites us is the approach - one model learning from ordinary labs and history - not the specific task.</a:t>
-            </a:r>
-          </a:p>
-          <a:p>
-            <a:r>
-              <a:t>We'd adapt that same approach to a question that fits Mayo: treatment response.</a:t>
-            </a:r>
-          </a:p>
-          <a:p>
-            <a:r>
-              <a:t>It's kicking off our dive into the related research.</a:t>
+              <a:rPr sz="1500"/>
+              <a:t>A 2026 Cell paper: one AI model reads routine clinical data over time to predict cancer outcomes.</a:t>
+            </a:r>
+          </a:p>
+          <a:p>
+            <a:r>
+              <a:rPr sz="1500"/>
+              <a:t>What excites us is the approach - not the specific task.</a:t>
+            </a:r>
+          </a:p>
+          <a:p>
+            <a:r>
+              <a:rPr sz="1500"/>
+              <a:t>We'd adapt it to a question that fits Mayo: treatment response.</a:t>
+            </a:r>
+          </a:p>
+          <a:p>
+            <a:r>
+              <a:rPr sz="1500"/>
+              <a:t>It kicks off our dive into the related research.</a:t>
+            </a:r>
+          </a:p>
+        </p:txBody>
+      </p:sp>
+      <p:pic>
+        <p:nvPicPr>
+          <p:cNvPr id="4" name="Picture 3" descr="oncoformer_fig.png"/>
+          <p:cNvPicPr>
+            <a:picLocks noChangeAspect="1"/>
+          </p:cNvPicPr>
+          <p:nvPr/>
+        </p:nvPicPr>
+        <p:blipFill>
+          <a:blip r:embed="rId2"/>
+          <a:stretch>
+            <a:fillRect/>
+          </a:stretch>
+        </p:blipFill>
+        <p:spPr>
+          <a:xfrm>
+            <a:off x="6720840" y="1920240"/>
+            <a:ext cx="3840480" cy="3840480"/>
+          </a:xfrm>
+          <a:prstGeom prst="rect">
+            <a:avLst/>
+          </a:prstGeom>
+        </p:spPr>
+      </p:pic>
+      <p:sp>
+        <p:nvSpPr>
+          <p:cNvPr id="5" name="TextBox 4"/>
+          <p:cNvSpPr txBox="1"/>
+          <p:nvPr/>
+        </p:nvSpPr>
+        <p:spPr>
+          <a:xfrm>
+            <a:off x="6720840" y="5852160"/>
+            <a:ext cx="4846320" cy="365760"/>
+          </a:xfrm>
+          <a:prstGeom prst="rect">
+            <a:avLst/>
+          </a:prstGeom>
+          <a:noFill/>
+        </p:spPr>
+        <p:txBody>
+          <a:bodyPr wrap="none">
+            <a:spAutoFit/>
+          </a:bodyPr>
+          <a:lstStyle/>
+          <a:p>
+            <a:r>
+              <a:rPr sz="900" i="1"/>
+              <a:t>Figure: Liu et al., Cell (2026), the Oncoformer paper</a:t>
             </a:r>
           </a:p>
         </p:txBody>

</xml_diff>

<commit_message>
Add mentor photos to slides 6-8; charts 1 and 5 now query-driven
</commit_message>
<xml_diff>
--- a/healthier_checkin_v2.pptx
+++ b/healthier_checkin_v2.pptx
@@ -17376,7 +17376,12 @@
             <p:ph idx="1"/>
           </p:nvPr>
         </p:nvSpPr>
-        <p:spPr/>
+        <p:spPr>
+          <a:xfrm>
+            <a:off x="822960" y="2103120"/>
+            <a:ext cx="8412480" cy="3931920"/>
+          </a:xfrm>
+        </p:spPr>
         <p:txBody>
           <a:bodyPr wrap="square"/>
           <a:lstStyle/>
@@ -17397,6 +17402,30 @@
           </a:p>
         </p:txBody>
       </p:sp>
+      <p:pic>
+        <p:nvPicPr>
+          <p:cNvPr id="4" name="Picture 3" descr="fetzer_face.png"/>
+          <p:cNvPicPr>
+            <a:picLocks noChangeAspect="1"/>
+          </p:cNvPicPr>
+          <p:nvPr/>
+        </p:nvPicPr>
+        <p:blipFill>
+          <a:blip r:embed="rId2"/>
+          <a:stretch>
+            <a:fillRect/>
+          </a:stretch>
+        </p:blipFill>
+        <p:spPr>
+          <a:xfrm>
+            <a:off x="9784080" y="2103120"/>
+            <a:ext cx="1828800" cy="1828800"/>
+          </a:xfrm>
+          <a:prstGeom prst="rect">
+            <a:avLst/>
+          </a:prstGeom>
+        </p:spPr>
+      </p:pic>
     </p:spTree>
   </p:cSld>
   <p:clrMapOvr>
@@ -17446,7 +17475,12 @@
             <p:ph idx="1"/>
           </p:nvPr>
         </p:nvSpPr>
-        <p:spPr/>
+        <p:spPr>
+          <a:xfrm>
+            <a:off x="822960" y="2103120"/>
+            <a:ext cx="8412480" cy="3931920"/>
+          </a:xfrm>
+        </p:spPr>
         <p:txBody>
           <a:bodyPr wrap="square"/>
           <a:lstStyle/>
@@ -17467,6 +17501,30 @@
           </a:p>
         </p:txBody>
       </p:sp>
+      <p:pic>
+        <p:nvPicPr>
+          <p:cNvPr id="4" name="Picture 3" descr="souaid_face.png"/>
+          <p:cNvPicPr>
+            <a:picLocks noChangeAspect="1"/>
+          </p:cNvPicPr>
+          <p:nvPr/>
+        </p:nvPicPr>
+        <p:blipFill>
+          <a:blip r:embed="rId2"/>
+          <a:stretch>
+            <a:fillRect/>
+          </a:stretch>
+        </p:blipFill>
+        <p:spPr>
+          <a:xfrm>
+            <a:off x="9784080" y="2103120"/>
+            <a:ext cx="1828800" cy="1828800"/>
+          </a:xfrm>
+          <a:prstGeom prst="rect">
+            <a:avLst/>
+          </a:prstGeom>
+        </p:spPr>
+      </p:pic>
     </p:spTree>
   </p:cSld>
   <p:clrMapOvr>
@@ -17516,7 +17574,12 @@
             <p:ph idx="1"/>
           </p:nvPr>
         </p:nvSpPr>
-        <p:spPr/>
+        <p:spPr>
+          <a:xfrm>
+            <a:off x="822960" y="2103120"/>
+            <a:ext cx="8412480" cy="3931920"/>
+          </a:xfrm>
+        </p:spPr>
         <p:txBody>
           <a:bodyPr wrap="square"/>
           <a:lstStyle/>
@@ -17537,6 +17600,30 @@
           </a:p>
         </p:txBody>
       </p:sp>
+      <p:pic>
+        <p:nvPicPr>
+          <p:cNvPr id="4" name="Picture 3" descr="rice_face.png"/>
+          <p:cNvPicPr>
+            <a:picLocks noChangeAspect="1"/>
+          </p:cNvPicPr>
+          <p:nvPr/>
+        </p:nvPicPr>
+        <p:blipFill>
+          <a:blip r:embed="rId2"/>
+          <a:stretch>
+            <a:fillRect/>
+          </a:stretch>
+        </p:blipFill>
+        <p:spPr>
+          <a:xfrm>
+            <a:off x="9784080" y="2103120"/>
+            <a:ext cx="1828800" cy="1828800"/>
+          </a:xfrm>
+          <a:prstGeom prst="rect">
+            <a:avLst/>
+          </a:prstGeom>
+        </p:spPr>
+      </p:pic>
     </p:spTree>
   </p:cSld>
   <p:clrMapOvr>

</xml_diff>

<commit_message>
Add Fetzer foundation-model slide before Oncoformer
</commit_message>
<xml_diff>
--- a/healthier_checkin_v2.pptx
+++ b/healthier_checkin_v2.pptx
@@ -18,6 +18,7 @@
     <p:sldId id="2147376798" r:id="rId20"/>
     <p:sldId id="2147376799" r:id="rId21"/>
     <p:sldId id="2147376800" r:id="rId22"/>
+    <p:sldId id="2147376801" r:id="rId23"/>
   </p:sldIdLst>
   <p:sldSz cx="12192000" cy="6858000"/>
   <p:notesSz cx="6858000" cy="9144000"/>
@@ -641,6 +642,76 @@
           <a:lstStyle/>
           <a:p>
             <a:r>
+              <a:t>Warm, honest close. It's going well, we're having fun, still scoping, will continue. Hands into the discussion.</a:t>
+            </a:r>
+          </a:p>
+        </p:txBody>
+      </p:sp>
+      <p:sp>
+        <p:nvSpPr>
+          <p:cNvPr id="4" name="Slide Number Placeholder 3"/>
+          <p:cNvSpPr>
+            <a:spLocks noGrp="1"/>
+          </p:cNvSpPr>
+          <p:nvPr>
+            <p:ph type="sldNum" idx="5" sz="quarter"/>
+          </p:nvPr>
+        </p:nvSpPr>
+        <p:spPr/>
+      </p:sp>
+    </p:spTree>
+  </p:cSld>
+  <p:clrMapOvr>
+    <a:masterClrMapping/>
+  </p:clrMapOvr>
+</p:notes>
+</file>
+
+<file path=ppt/notesSlides/notesSlide11.xml><?xml version="1.0" encoding="utf-8"?>
+<p:notes xmlns:a="http://schemas.openxmlformats.org/drawingml/2006/main" xmlns:p="http://schemas.openxmlformats.org/presentationml/2006/main" xmlns:r="http://schemas.openxmlformats.org/officeDocument/2006/relationships">
+  <p:cSld>
+    <p:spTree>
+      <p:nvGrpSpPr>
+        <p:cNvPr id="1" name=""/>
+        <p:cNvGrpSpPr/>
+        <p:nvPr/>
+      </p:nvGrpSpPr>
+      <p:grpSpPr>
+        <a:xfrm>
+          <a:off x="0" y="0"/>
+          <a:ext cx="0" cy="0"/>
+          <a:chOff x="0" y="0"/>
+          <a:chExt cx="0" cy="0"/>
+        </a:xfrm>
+      </p:grpSpPr>
+      <p:sp>
+        <p:nvSpPr>
+          <p:cNvPr id="2" name="Slide Image Placeholder 1"/>
+          <p:cNvSpPr>
+            <a:spLocks noGrp="1"/>
+          </p:cNvSpPr>
+          <p:nvPr>
+            <p:ph type="sldImg" idx="2"/>
+          </p:nvPr>
+        </p:nvSpPr>
+        <p:spPr/>
+      </p:sp>
+      <p:sp>
+        <p:nvSpPr>
+          <p:cNvPr id="3" name="Notes Placeholder 2"/>
+          <p:cNvSpPr>
+            <a:spLocks noGrp="1"/>
+          </p:cNvSpPr>
+          <p:nvPr>
+            <p:ph type="body" idx="3" sz="quarter"/>
+          </p:nvPr>
+        </p:nvSpPr>
+        <p:spPr/>
+        <p:txBody>
+          <a:bodyPr/>
+          <a:lstStyle/>
+          <a:p>
+            <a:r>
               <a:t>Leave time for the 20-minute discussion.</a:t>
             </a:r>
           </a:p>
@@ -921,7 +992,7 @@
           <a:lstStyle/>
           <a:p>
             <a:r>
-              <a:t>IMPORTANT bridge: Oncoformer is technically an early-detection model, but we said no to early detection. So be explicit: it inspires our METHOD, not our TASK. We adapt the approach to treatment response. The figure is the authors' own - cite it.</a:t>
+              <a:t>Cite Fetzer FIRST as a Mayo-local proof point. Everything here is from his own advisor profile and public work - do NOT add a formal paper citation we haven't verified, since he'll be in the room. The point: this approach already works at Mayo, one modality over.</a:t>
             </a:r>
           </a:p>
         </p:txBody>
@@ -991,7 +1062,7 @@
           <a:lstStyle/>
           <a:p>
             <a:r>
-              <a:t>The bullseye technical mentor. He literally built a foundation model on Mayo data and knows the compute and validation constraints we're hitting.</a:t>
+              <a:t>IMPORTANT bridge: Oncoformer is technically an early-detection model, but we said no to early detection. So be explicit: it inspires our METHOD, not our TASK. We adapt the approach to treatment response. The figure is the authors' own - cite it.</a:t>
             </a:r>
           </a:p>
         </p:txBody>
@@ -1061,7 +1132,7 @@
           <a:lstStyle/>
           <a:p>
             <a:r>
-              <a:t>Our clinical grounding + evaluation expertise. Keeps the study clinically honest.</a:t>
+              <a:t>The bullseye technical mentor. He literally built a foundation model on Mayo data and knows the compute and validation constraints we're hitting.</a:t>
             </a:r>
           </a:p>
         </p:txBody>
@@ -1131,7 +1202,7 @@
           <a:lstStyle/>
           <a:p>
             <a:r>
-              <a:t>Our business/commercial mentor (vs. the two technical ones). Parth specifically wants employer-sponsored go-to-market support. Frame honestly - she's the commercial pick.</a:t>
+              <a:t>Our clinical grounding + evaluation expertise. Keeps the study clinically honest.</a:t>
             </a:r>
           </a:p>
         </p:txBody>
@@ -1201,7 +1272,7 @@
           <a:lstStyle/>
           <a:p>
             <a:r>
-              <a:t>Warm, honest close. It's going well, we're having fun, still scoping, will continue. Hands into the discussion.</a:t>
+              <a:t>Our business/commercial mentor (vs. the two technical ones). Parth specifically wants employer-sponsored go-to-market support. Frame honestly - she's the commercial pick.</a:t>
             </a:r>
           </a:p>
         </p:txBody>
@@ -16690,7 +16761,7 @@
           <a:lstStyle/>
           <a:p>
             <a:r>
-              <a:t>How it's going</a:t>
+              <a:t>Mentor 3  -  Elizabeth Rice  (Mayo Clinic)</a:t>
             </a:r>
           </a:p>
         </p:txBody>
@@ -16705,32 +16776,56 @@
             <p:ph idx="1"/>
           </p:nvPr>
         </p:nvSpPr>
-        <p:spPr/>
+        <p:spPr>
+          <a:xfrm>
+            <a:off x="822960" y="2103120"/>
+            <a:ext cx="8412480" cy="3931920"/>
+          </a:xfrm>
+        </p:spPr>
         <p:txBody>
           <a:bodyPr wrap="square"/>
           <a:lstStyle/>
           <a:p>
             <a:r>
-              <a:t>The environment is working well and we're genuinely enjoying digging into the data.</a:t>
-            </a:r>
-          </a:p>
-          <a:p>
-            <a:r>
-              <a:t>We understand the data far better than when we started.</a:t>
-            </a:r>
-          </a:p>
-          <a:p>
-            <a:r>
-              <a:t>Still scoping: the exact model, the specifics around trials and treatments, and the final study design.</a:t>
-            </a:r>
-          </a:p>
-          <a:p>
-            <a:r>
-              <a:t>Next: lock the study question with our mentors, then start building.</a:t>
-            </a:r>
-          </a:p>
-        </p:txBody>
-      </p:sp>
+              <a:t>Who: a healthcare commercial strategist - payers, employers, and market access.</a:t>
+            </a:r>
+          </a:p>
+          <a:p>
+            <a:r>
+              <a:t>Why we value her: as we think about how this eventually reaches patients, she knows employer-sponsored and payer go-to-market.</a:t>
+            </a:r>
+          </a:p>
+          <a:p>
+            <a:r>
+              <a:t>How we'll engage: guidance on our commercial strategy, especially employer-sponsored go-to-market.</a:t>
+            </a:r>
+          </a:p>
+        </p:txBody>
+      </p:sp>
+      <p:pic>
+        <p:nvPicPr>
+          <p:cNvPr id="4" name="Picture 3" descr="rice_face.png"/>
+          <p:cNvPicPr>
+            <a:picLocks noChangeAspect="1"/>
+          </p:cNvPicPr>
+          <p:nvPr/>
+        </p:nvPicPr>
+        <p:blipFill>
+          <a:blip r:embed="rId2"/>
+          <a:stretch>
+            <a:fillRect/>
+          </a:stretch>
+        </p:blipFill>
+        <p:spPr>
+          <a:xfrm>
+            <a:off x="9784080" y="2103120"/>
+            <a:ext cx="1828800" cy="1828800"/>
+          </a:xfrm>
+          <a:prstGeom prst="rect">
+            <a:avLst/>
+          </a:prstGeom>
+        </p:spPr>
+      </p:pic>
     </p:spTree>
   </p:cSld>
   <p:clrMapOvr>
@@ -16751,6 +16846,81 @@
       <p:grpSpPr/>
       <p:sp>
         <p:nvSpPr>
+          <p:cNvPr id="2" name="Title 1"/>
+          <p:cNvSpPr>
+            <a:spLocks noGrp="1"/>
+          </p:cNvSpPr>
+          <p:nvPr>
+            <p:ph type="title"/>
+          </p:nvPr>
+        </p:nvSpPr>
+        <p:spPr/>
+        <p:txBody>
+          <a:bodyPr/>
+          <a:lstStyle/>
+          <a:p>
+            <a:r>
+              <a:t>How it's going</a:t>
+            </a:r>
+          </a:p>
+        </p:txBody>
+      </p:sp>
+      <p:sp>
+        <p:nvSpPr>
+          <p:cNvPr id="3" name="Content Placeholder 2"/>
+          <p:cNvSpPr>
+            <a:spLocks noGrp="1"/>
+          </p:cNvSpPr>
+          <p:nvPr>
+            <p:ph idx="1"/>
+          </p:nvPr>
+        </p:nvSpPr>
+        <p:spPr/>
+        <p:txBody>
+          <a:bodyPr wrap="square"/>
+          <a:lstStyle/>
+          <a:p>
+            <a:r>
+              <a:t>The environment is working well and we're genuinely enjoying digging into the data.</a:t>
+            </a:r>
+          </a:p>
+          <a:p>
+            <a:r>
+              <a:t>We understand the data far better than when we started.</a:t>
+            </a:r>
+          </a:p>
+          <a:p>
+            <a:r>
+              <a:t>Still scoping: the exact model, the specifics around trials and treatments, and the final study design.</a:t>
+            </a:r>
+          </a:p>
+          <a:p>
+            <a:r>
+              <a:t>Next: lock the study question with our mentors, then start building.</a:t>
+            </a:r>
+          </a:p>
+        </p:txBody>
+      </p:sp>
+    </p:spTree>
+  </p:cSld>
+  <p:clrMapOvr>
+    <a:masterClrMapping/>
+  </p:clrMapOvr>
+</p:sld>
+</file>
+
+<file path=ppt/slides/slide12.xml><?xml version="1.0" encoding="utf-8"?>
+<p:sld xmlns:a="http://schemas.openxmlformats.org/drawingml/2006/main" xmlns:p="http://schemas.openxmlformats.org/presentationml/2006/main" xmlns:r="http://schemas.openxmlformats.org/officeDocument/2006/relationships">
+  <p:cSld>
+    <p:spTree>
+      <p:nvGrpSpPr>
+        <p:cNvPr id="1" name=""/>
+        <p:cNvGrpSpPr/>
+        <p:nvPr/>
+      </p:nvGrpSpPr>
+      <p:grpSpPr/>
+      <p:sp>
+        <p:nvSpPr>
           <p:cNvPr id="2" name="Text Placeholder 1"/>
           <p:cNvSpPr>
             <a:spLocks noGrp="1"/>
@@ -17224,7 +17394,7 @@
           <a:lstStyle/>
           <a:p>
             <a:r>
-              <a:t>Our inspiration: the Oncoformer study</a:t>
+              <a:t>Mayo is already proving this works</a:t>
             </a:r>
           </a:p>
         </p:txBody>
@@ -17239,90 +17409,28 @@
             <p:ph idx="1"/>
           </p:nvPr>
         </p:nvSpPr>
-        <p:spPr>
-          <a:xfrm>
-            <a:off x="822960" y="2103120"/>
-            <a:ext cx="5577840" cy="3931920"/>
-          </a:xfrm>
-        </p:spPr>
+        <p:spPr/>
         <p:txBody>
           <a:bodyPr wrap="square"/>
           <a:lstStyle/>
           <a:p>
             <a:r>
-              <a:rPr sz="1500"/>
-              <a:t>A 2026 Cell paper: one AI model reads routine clinical data over time to predict cancer outcomes.</a:t>
-            </a:r>
-          </a:p>
-          <a:p>
-            <a:r>
-              <a:rPr sz="1500"/>
-              <a:t>What excites us is the approach - not the specific task.</a:t>
-            </a:r>
-          </a:p>
-          <a:p>
-            <a:r>
-              <a:rPr sz="1500"/>
-              <a:t>We'd adapt it to a question that fits Mayo: treatment response.</a:t>
-            </a:r>
-          </a:p>
-          <a:p>
-            <a:r>
-              <a:rPr sz="1500"/>
-              <a:t>It kicks off our dive into the related research.</a:t>
-            </a:r>
-          </a:p>
-        </p:txBody>
-      </p:sp>
-      <p:pic>
-        <p:nvPicPr>
-          <p:cNvPr id="4" name="Picture 3" descr="oncoformer_fig.png"/>
-          <p:cNvPicPr>
-            <a:picLocks noChangeAspect="1"/>
-          </p:cNvPicPr>
-          <p:nvPr/>
-        </p:nvPicPr>
-        <p:blipFill>
-          <a:blip r:embed="rId2"/>
-          <a:stretch>
-            <a:fillRect/>
-          </a:stretch>
-        </p:blipFill>
-        <p:spPr>
-          <a:xfrm>
-            <a:off x="6720840" y="1920240"/>
-            <a:ext cx="3840480" cy="3840480"/>
-          </a:xfrm>
-          <a:prstGeom prst="rect">
-            <a:avLst/>
-          </a:prstGeom>
-        </p:spPr>
-      </p:pic>
-      <p:sp>
-        <p:nvSpPr>
-          <p:cNvPr id="5" name="TextBox 4"/>
-          <p:cNvSpPr txBox="1"/>
-          <p:nvPr/>
-        </p:nvSpPr>
-        <p:spPr>
-          <a:xfrm>
-            <a:off x="6720840" y="5852160"/>
-            <a:ext cx="4846320" cy="365760"/>
-          </a:xfrm>
-          <a:prstGeom prst="rect">
-            <a:avLst/>
-          </a:prstGeom>
-          <a:noFill/>
-        </p:spPr>
-        <p:txBody>
-          <a:bodyPr wrap="none">
-            <a:spAutoFit/>
-          </a:bodyPr>
-          <a:lstStyle/>
-          <a:p>
-            <a:r>
-              <a:rPr sz="900" i="1"/>
-              <a:t>Figure: Liu et al., Cell (2026), the Oncoformer paper</a:t>
+              <a:t>Our mentor Jeffrey Fetzer (Mayo GI AI Lab) built a foundation model on 50,000+ Mayo endoscopy videos.</a:t>
+            </a:r>
+          </a:p>
+          <a:p>
+            <a:r>
+              <a:t>It learns from Mayo's own clinical data with self-supervised learning - exactly the approach we want to take.</a:t>
+            </a:r>
+          </a:p>
+          <a:p>
+            <a:r>
+              <a:t>His is imaging (endoscopy video); ours would be lab and vital-sign history. Same playbook, different data.</a:t>
+            </a:r>
+          </a:p>
+          <a:p>
+            <a:r>
+              <a:t>Proof that a foundation model can be built and validated inside this environment.</a:t>
             </a:r>
           </a:p>
         </p:txBody>
@@ -17361,7 +17469,7 @@
           <a:lstStyle/>
           <a:p>
             <a:r>
-              <a:t>Mentor 1  -  Jeffrey Fetzer, PhD  (Mayo Clinic)</a:t>
+              <a:t>Our inspiration: the Oncoformer study</a:t>
             </a:r>
           </a:p>
         </p:txBody>
@@ -17379,7 +17487,7 @@
         <p:spPr>
           <a:xfrm>
             <a:off x="822960" y="2103120"/>
-            <a:ext cx="8412480" cy="3931920"/>
+            <a:ext cx="5577840" cy="3931920"/>
           </a:xfrm>
         </p:spPr>
         <p:txBody>
@@ -17387,24 +17495,33 @@
           <a:lstStyle/>
           <a:p>
             <a:r>
-              <a:t>Who: a Mayo AI scientist who built a large medical-AI model on Mayo's own data.</a:t>
-            </a:r>
-          </a:p>
-          <a:p>
-            <a:r>
-              <a:t>Why we value him: he has already done what we're attempting - building and validating an AI model inside Mayo's environment - and cares about doing it rigorously.</a:t>
-            </a:r>
-          </a:p>
-          <a:p>
-            <a:r>
-              <a:t>How we'll engage: guidance on model design, on proving the results hold up, and on working within the data environment's limits.</a:t>
+              <a:rPr sz="1500"/>
+              <a:t>A 2026 Cell paper: one AI model reads routine clinical data over time to predict cancer outcomes.</a:t>
+            </a:r>
+          </a:p>
+          <a:p>
+            <a:r>
+              <a:rPr sz="1500"/>
+              <a:t>What excites us is the approach - not the specific task.</a:t>
+            </a:r>
+          </a:p>
+          <a:p>
+            <a:r>
+              <a:rPr sz="1500"/>
+              <a:t>We'd adapt it to a question that fits Mayo: treatment response.</a:t>
+            </a:r>
+          </a:p>
+          <a:p>
+            <a:r>
+              <a:rPr sz="1500"/>
+              <a:t>It kicks off our dive into the related research.</a:t>
             </a:r>
           </a:p>
         </p:txBody>
       </p:sp>
       <p:pic>
         <p:nvPicPr>
-          <p:cNvPr id="4" name="Picture 3" descr="fetzer_face.png"/>
+          <p:cNvPr id="4" name="Picture 3" descr="oncoformer_fig.png"/>
           <p:cNvPicPr>
             <a:picLocks noChangeAspect="1"/>
           </p:cNvPicPr>
@@ -17418,14 +17535,43 @@
         </p:blipFill>
         <p:spPr>
           <a:xfrm>
-            <a:off x="9784080" y="2103120"/>
-            <a:ext cx="1828800" cy="1828800"/>
+            <a:off x="6720840" y="1920240"/>
+            <a:ext cx="3840480" cy="3840480"/>
           </a:xfrm>
           <a:prstGeom prst="rect">
             <a:avLst/>
           </a:prstGeom>
         </p:spPr>
       </p:pic>
+      <p:sp>
+        <p:nvSpPr>
+          <p:cNvPr id="5" name="TextBox 4"/>
+          <p:cNvSpPr txBox="1"/>
+          <p:nvPr/>
+        </p:nvSpPr>
+        <p:spPr>
+          <a:xfrm>
+            <a:off x="6720840" y="5852160"/>
+            <a:ext cx="4846320" cy="365760"/>
+          </a:xfrm>
+          <a:prstGeom prst="rect">
+            <a:avLst/>
+          </a:prstGeom>
+          <a:noFill/>
+        </p:spPr>
+        <p:txBody>
+          <a:bodyPr wrap="none">
+            <a:spAutoFit/>
+          </a:bodyPr>
+          <a:lstStyle/>
+          <a:p>
+            <a:r>
+              <a:rPr sz="900" i="1"/>
+              <a:t>Figure: Liu et al., Cell (2026), the Oncoformer paper</a:t>
+            </a:r>
+          </a:p>
+        </p:txBody>
+      </p:sp>
     </p:spTree>
   </p:cSld>
   <p:clrMapOvr>
@@ -17460,7 +17606,7 @@
           <a:lstStyle/>
           <a:p>
             <a:r>
-              <a:t>Mentor 2  -  Tarek Souaid, MD MPH  (Mayo Clinic)</a:t>
+              <a:t>Mentor 1  -  Jeffrey Fetzer, PhD  (Mayo Clinic)</a:t>
             </a:r>
           </a:p>
         </p:txBody>
@@ -17486,24 +17632,24 @@
           <a:lstStyle/>
           <a:p>
             <a:r>
-              <a:t>Who: a Mayo physician focused on evaluating AI in real clinical workflows.</a:t>
-            </a:r>
-          </a:p>
-          <a:p>
-            <a:r>
-              <a:t>Why we value him: a doctor who can tell us whether our patient groups and outcomes make clinical sense - and who works on how to judge whether an AI model is any good.</a:t>
-            </a:r>
-          </a:p>
-          <a:p>
-            <a:r>
-              <a:t>How we'll engage: clinical sanity-checks on the study, and advice on how we measure success.</a:t>
+              <a:t>Who: a Mayo AI scientist who built a large medical-AI model on Mayo's own data.</a:t>
+            </a:r>
+          </a:p>
+          <a:p>
+            <a:r>
+              <a:t>Why we value him: he has already done what we're attempting - building and validating an AI model inside Mayo's environment - and cares about doing it rigorously.</a:t>
+            </a:r>
+          </a:p>
+          <a:p>
+            <a:r>
+              <a:t>How we'll engage: guidance on model design, on proving the results hold up, and on working within the data environment's limits.</a:t>
             </a:r>
           </a:p>
         </p:txBody>
       </p:sp>
       <p:pic>
         <p:nvPicPr>
-          <p:cNvPr id="4" name="Picture 3" descr="souaid_face.png"/>
+          <p:cNvPr id="4" name="Picture 3" descr="fetzer_face.png"/>
           <p:cNvPicPr>
             <a:picLocks noChangeAspect="1"/>
           </p:cNvPicPr>
@@ -17559,7 +17705,7 @@
           <a:lstStyle/>
           <a:p>
             <a:r>
-              <a:t>Mentor 3  -  Elizabeth Rice  (Mayo Clinic)</a:t>
+              <a:t>Mentor 2  -  Tarek Souaid, MD MPH  (Mayo Clinic)</a:t>
             </a:r>
           </a:p>
         </p:txBody>
@@ -17585,24 +17731,24 @@
           <a:lstStyle/>
           <a:p>
             <a:r>
-              <a:t>Who: a healthcare commercial strategist - payers, employers, and market access.</a:t>
-            </a:r>
-          </a:p>
-          <a:p>
-            <a:r>
-              <a:t>Why we value her: as we think about how this eventually reaches patients, she knows employer-sponsored and payer go-to-market.</a:t>
-            </a:r>
-          </a:p>
-          <a:p>
-            <a:r>
-              <a:t>How we'll engage: guidance on our commercial strategy, especially employer-sponsored go-to-market.</a:t>
+              <a:t>Who: a Mayo physician focused on evaluating AI in real clinical workflows.</a:t>
+            </a:r>
+          </a:p>
+          <a:p>
+            <a:r>
+              <a:t>Why we value him: a doctor who can tell us whether our patient groups and outcomes make clinical sense - and who works on how to judge whether an AI model is any good.</a:t>
+            </a:r>
+          </a:p>
+          <a:p>
+            <a:r>
+              <a:t>How we'll engage: clinical sanity-checks on the study, and advice on how we measure success.</a:t>
             </a:r>
           </a:p>
         </p:txBody>
       </p:sp>
       <p:pic>
         <p:nvPicPr>
-          <p:cNvPr id="4" name="Picture 3" descr="rice_face.png"/>
+          <p:cNvPr id="4" name="Picture 3" descr="souaid_face.png"/>
           <p:cNvPicPr>
             <a:picLocks noChangeAspect="1"/>
           </p:cNvPicPr>

</xml_diff>